<commit_message>
Presentación de avance: diapositiva de evaluación de detección con YOLO (Figura 7)
</commit_message>
<xml_diff>
--- a/docs/Tesis_Avance_Presentacion.pptx
+++ b/docs/Tesis_Avance_Presentacion.pptx
@@ -21,6 +21,7 @@
     <p:sldId id="269" r:id="rId15"/>
     <p:sldId id="274" r:id="rId25"/>
     <p:sldId id="275" r:id="rId26"/>
+    <p:sldId id="276" r:id="rId27"/>
     <p:sldId id="270" r:id="rId16"/>
     <p:sldId id="271" r:id="rId17"/>
     <p:sldId id="272" r:id="rId18"/>
@@ -2953,7 +2954,7 @@
                 <a:ea typeface="Calibri" pitchFamily="34" charset="-122"/>
                 <a:cs typeface="Calibri" pitchFamily="34" charset="-120"/>
               </a:rPr>
-              <a:t>10 / 20</a:t>
+              <a:t>10 / 21</a:t>
             </a:r>
             <a:endParaRPr lang="en-US" sz="1000" dirty="0"/>
           </a:p>
@@ -4531,7 +4532,7 @@
                 <a:ea typeface="Calibri" pitchFamily="34" charset="-122"/>
                 <a:cs typeface="Calibri" pitchFamily="34" charset="-120"/>
               </a:rPr>
-              <a:t>11 / 20</a:t>
+              <a:t>11 / 21</a:t>
             </a:r>
             <a:endParaRPr lang="en-US" sz="1000" dirty="0"/>
           </a:p>
@@ -8645,7 +8646,7 @@
                 <a:ea typeface="Calibri" pitchFamily="34" charset="-122"/>
                 <a:cs typeface="Calibri" pitchFamily="34" charset="-120"/>
               </a:rPr>
-              <a:t>12 / 20</a:t>
+              <a:t>12 / 21</a:t>
             </a:r>
             <a:endParaRPr lang="en-US" sz="1000" dirty="0"/>
           </a:p>
@@ -8908,7 +8909,7 @@
                 <a:ea typeface="Calibri" pitchFamily="34" charset="-122"/>
                 <a:cs typeface="Calibri" pitchFamily="34" charset="-120"/>
               </a:rPr>
-              <a:t>13 / 20</a:t>
+              <a:t>13 / 21</a:t>
             </a:r>
             <a:endParaRPr lang="en-US" sz="1000" dirty="0"/>
           </a:p>
@@ -10734,7 +10735,7 @@
                 <a:ea typeface="Calibri" pitchFamily="34" charset="-122"/>
                 <a:cs typeface="Calibri" pitchFamily="34" charset="-120"/>
               </a:rPr>
-              <a:t>14 / 20</a:t>
+              <a:t>14 / 21</a:t>
             </a:r>
             <a:endParaRPr lang="en-US" sz="1000" dirty="0"/>
           </a:p>
@@ -10983,7 +10984,7 @@
                 <a:ea typeface="Calibri" pitchFamily="34" charset="-122"/>
                 <a:cs typeface="Calibri" pitchFamily="34" charset="-120"/>
               </a:rPr>
-              <a:t>15 / 20</a:t>
+              <a:t>15 / 21</a:t>
             </a:r>
             <a:endParaRPr lang="en-US" sz="1000" dirty="0"/>
           </a:p>
@@ -11232,7 +11233,7 @@
                 <a:ea typeface="Calibri" pitchFamily="34" charset="-122"/>
                 <a:cs typeface="Calibri" pitchFamily="34" charset="-120"/>
               </a:rPr>
-              <a:t>16 / 20</a:t>
+              <a:t>16 / 21</a:t>
             </a:r>
             <a:endParaRPr lang="en-US" sz="1000" dirty="0"/>
           </a:p>
@@ -11495,7 +11496,7 @@
                 <a:ea typeface="Calibri" pitchFamily="34" charset="-122"/>
                 <a:cs typeface="Calibri" pitchFamily="34" charset="-120"/>
               </a:rPr>
-              <a:t>17 / 20</a:t>
+              <a:t>18 / 21</a:t>
             </a:r>
             <a:endParaRPr lang="en-US" sz="1000" dirty="0"/>
           </a:p>
@@ -12403,7 +12404,7 @@
                 <a:ea typeface="Calibri" pitchFamily="34" charset="-122"/>
                 <a:cs typeface="Calibri" pitchFamily="34" charset="-120"/>
               </a:rPr>
-              <a:t>18 / 20</a:t>
+              <a:t>19 / 21</a:t>
             </a:r>
             <a:endParaRPr lang="en-US" sz="1000" dirty="0"/>
           </a:p>
@@ -13113,7 +13114,7 @@
                 <a:ea typeface="Calibri" pitchFamily="34" charset="-122"/>
                 <a:cs typeface="Calibri" pitchFamily="34" charset="-120"/>
               </a:rPr>
-              <a:t>19 / 20</a:t>
+              <a:t>20 / 21</a:t>
             </a:r>
             <a:endParaRPr lang="en-US" sz="1000" dirty="0"/>
           </a:p>
@@ -13940,7 +13941,7 @@
                 <a:ea typeface="Calibri" pitchFamily="34" charset="-122"/>
                 <a:cs typeface="Calibri" pitchFamily="34" charset="-120"/>
               </a:rPr>
-              <a:t>2 / 20</a:t>
+              <a:t>2 / 21</a:t>
             </a:r>
             <a:endParaRPr lang="en-US" sz="1000" dirty="0"/>
           </a:p>
@@ -14898,6 +14899,255 @@
 </p:sld>
 </file>
 
+<file path=ppt/slides/slide21.xml><?xml version="1.0" encoding="utf-8"?>
+<p:sld xmlns:a="http://schemas.openxmlformats.org/drawingml/2006/main" xmlns:p="http://schemas.openxmlformats.org/presentationml/2006/main" xmlns:r="http://schemas.openxmlformats.org/officeDocument/2006/relationships">
+  <p:cSld>
+    <p:spTree>
+      <p:nvGrpSpPr>
+        <p:cNvPr id="1" name=""/>
+        <p:cNvGrpSpPr/>
+        <p:nvPr/>
+      </p:nvGrpSpPr>
+      <p:grpSpPr/>
+      <p:sp>
+        <p:nvSpPr>
+          <p:cNvPr id="2" name="Shape 0"/>
+          <p:cNvSpPr/>
+          <p:nvPr/>
+        </p:nvSpPr>
+        <p:spPr>
+          <a:xfrm>
+            <a:off x="0" y="0"/>
+            <a:ext cx="320040" cy="6858000"/>
+          </a:xfrm>
+          <a:prstGeom prst="rect">
+            <a:avLst/>
+          </a:prstGeom>
+          <a:solidFill>
+            <a:srgbClr val="1E2761"/>
+          </a:solidFill>
+          <a:ln/>
+        </p:spPr>
+        <p:txBody>
+          <a:bodyPr/>
+          <a:p/>
+        </p:txBody>
+      </p:sp>
+      <p:sp>
+        <p:nvSpPr>
+          <p:cNvPr id="3" name="Text 1"/>
+          <p:cNvSpPr/>
+          <p:nvPr/>
+        </p:nvSpPr>
+        <p:spPr>
+          <a:xfrm>
+            <a:off x="640080" y="320040"/>
+            <a:ext cx="10607040" cy="640080"/>
+          </a:xfrm>
+          <a:prstGeom prst="rect">
+            <a:avLst/>
+          </a:prstGeom>
+          <a:noFill/>
+          <a:ln/>
+        </p:spPr>
+        <p:txBody>
+          <a:bodyPr wrap="square" lIns="0" tIns="0" rIns="0" bIns="0" rtlCol="0" anchor="ctr"/>
+          <a:lstStyle/>
+          <a:p>
+            <a:pPr indent="0" marL="0">
+              <a:buNone/>
+            </a:pPr>
+            <a:r>
+              <a:rPr lang="en-US" sz="2800" b="1" dirty="0">
+                <a:solidFill>
+                  <a:srgbClr val="1E2761"/>
+                </a:solidFill>
+                <a:latin typeface="Georgia" pitchFamily="34" charset="0"/>
+                <a:ea typeface="Georgia" pitchFamily="34" charset="-122"/>
+                <a:cs typeface="Georgia" pitchFamily="34" charset="-120"/>
+              </a:rPr>
+              <a:t>Evaluación orientada a tarea: detección con YOLO</a:t>
+            </a:r>
+            <a:endParaRPr lang="en-US" sz="2800" dirty="0"/>
+          </a:p>
+        </p:txBody>
+      </p:sp>
+      <p:sp>
+        <p:nvSpPr>
+          <p:cNvPr id="4" name="Shape 2"/>
+          <p:cNvSpPr/>
+          <p:nvPr/>
+        </p:nvSpPr>
+        <p:spPr>
+          <a:xfrm>
+            <a:off x="640080" y="960120"/>
+            <a:ext cx="10881360" cy="0"/>
+          </a:xfrm>
+          <a:prstGeom prst="line">
+            <a:avLst/>
+          </a:prstGeom>
+          <a:noFill/>
+          <a:ln w="19050">
+            <a:solidFill>
+              <a:srgbClr val="CADCFC"/>
+            </a:solidFill>
+            <a:prstDash val="solid"/>
+          </a:ln>
+        </p:spPr>
+        <p:txBody>
+          <a:bodyPr/>
+          <a:p/>
+        </p:txBody>
+      </p:sp>
+      <p:sp>
+        <p:nvSpPr>
+          <p:cNvPr id="5" name="Text 3"/>
+          <p:cNvSpPr/>
+          <p:nvPr/>
+        </p:nvSpPr>
+        <p:spPr>
+          <a:xfrm>
+            <a:off x="640080" y="6492240"/>
+            <a:ext cx="6400800" cy="274320"/>
+          </a:xfrm>
+          <a:prstGeom prst="rect">
+            <a:avLst/>
+          </a:prstGeom>
+          <a:noFill/>
+          <a:ln/>
+        </p:spPr>
+        <p:txBody>
+          <a:bodyPr wrap="square" lIns="0" tIns="0" rIns="0" bIns="0" rtlCol="0" anchor="ctr"/>
+          <a:lstStyle/>
+          <a:p>
+            <a:pPr indent="0" marL="0">
+              <a:buNone/>
+            </a:pPr>
+            <a:r>
+              <a:rPr lang="en-US" sz="1000" i="1" dirty="0">
+                <a:solidFill>
+                  <a:srgbClr val="64748B"/>
+                </a:solidFill>
+                <a:latin typeface="Calibri" pitchFamily="34" charset="0"/>
+                <a:ea typeface="Calibri" pitchFamily="34" charset="-122"/>
+                <a:cs typeface="Calibri" pitchFamily="34" charset="-120"/>
+              </a:rPr>
+              <a:t>Tesis Maestría en Ciencias de Datos — UCOM</a:t>
+            </a:r>
+            <a:endParaRPr lang="en-US" sz="1000" dirty="0"/>
+          </a:p>
+        </p:txBody>
+      </p:sp>
+      <p:sp>
+        <p:nvSpPr>
+          <p:cNvPr id="6" name="Text 4"/>
+          <p:cNvSpPr/>
+          <p:nvPr/>
+        </p:nvSpPr>
+        <p:spPr>
+          <a:xfrm>
+            <a:off x="11064240" y="6492240"/>
+            <a:ext cx="457200" cy="274320"/>
+          </a:xfrm>
+          <a:prstGeom prst="rect">
+            <a:avLst/>
+          </a:prstGeom>
+          <a:noFill/>
+          <a:ln/>
+        </p:spPr>
+        <p:txBody>
+          <a:bodyPr wrap="square" lIns="0" tIns="0" rIns="0" bIns="0" rtlCol="0" anchor="ctr"/>
+          <a:lstStyle/>
+          <a:p>
+            <a:pPr algn="r" indent="0" marL="0">
+              <a:buNone/>
+            </a:pPr>
+            <a:r>
+              <a:rPr lang="en-US" sz="1000" dirty="0">
+                <a:solidFill>
+                  <a:srgbClr val="64748B"/>
+                </a:solidFill>
+                <a:latin typeface="Calibri" pitchFamily="34" charset="0"/>
+                <a:ea typeface="Calibri" pitchFamily="34" charset="-122"/>
+                <a:cs typeface="Calibri" pitchFamily="34" charset="-120"/>
+              </a:rPr>
+              <a:t>17 / 21</a:t>
+            </a:r>
+            <a:endParaRPr lang="en-US" sz="1000" dirty="0"/>
+          </a:p>
+        </p:txBody>
+      </p:sp>
+      <p:pic>
+        <p:nvPicPr>
+          <p:cNvPr id="7" name="Image 0" descr="/sessions/modest-affectionate-curie/mnt/mastertesis/tesis_mciencias_datos/docs/figures/fig_heatmap_tophat.png">    </p:cNvPr>
+          <p:cNvPicPr>
+            <a:picLocks noChangeAspect="1"/>
+          </p:cNvPicPr>
+          <p:nvPr/>
+        </p:nvPicPr>
+        <p:blipFill>
+          <a:blip r:embed="rId2"/>
+          <a:stretch>
+            <a:fillRect/>
+          </a:stretch>
+        </p:blipFill>
+        <p:spPr>
+          <a:xfrm>
+            <a:off x="365760" y="1188720"/>
+            <a:ext cx="11430000" cy="4408714"/>
+          </a:xfrm>
+          <a:prstGeom prst="rect">
+            <a:avLst/>
+          </a:prstGeom>
+        </p:spPr>
+      </p:pic>
+      <p:sp>
+        <p:nvSpPr>
+          <p:cNvPr id="8" name="Text 5"/>
+          <p:cNvSpPr/>
+          <p:nvPr/>
+        </p:nvSpPr>
+        <p:spPr>
+          <a:xfrm>
+            <a:off x="640080" y="6263640"/>
+            <a:ext cx="10881360" cy="365760"/>
+          </a:xfrm>
+          <a:prstGeom prst="rect">
+            <a:avLst/>
+          </a:prstGeom>
+          <a:noFill/>
+          <a:ln/>
+        </p:spPr>
+        <p:txBody>
+          <a:bodyPr wrap="square" lIns="0" tIns="0" rIns="0" bIns="0" rtlCol="0" anchor="ctr"/>
+          <a:lstStyle/>
+          <a:p>
+            <a:pPr algn="ctr" indent="0" marL="0">
+              <a:buNone/>
+            </a:pPr>
+            <a:r>
+              <a:rPr lang="en-US" sz="1100" i="1" dirty="0">
+                <a:solidFill>
+                  <a:srgbClr val="1E2761"/>
+                </a:solidFill>
+                <a:latin typeface="Calibri" pitchFamily="34" charset="0"/>
+                <a:ea typeface="Calibri" pitchFamily="34" charset="-122"/>
+                <a:cs typeface="Calibri" pitchFamily="34" charset="-120"/>
+              </a:rPr>
+              <a:t>YOLOv8n (inferencia, sin etiquetas): en VIS se detecta solo 1 persona; con fusión sube a 13 (WTH) y 16 (+BTH). VIS favorece vehículos, IR/fusión personas; la fusión WTH equilibra ambas (13 personas, 12 vehículos). Diferencias entre métodos no significativas (n=20); mAP pendiente con dataset etiquetado.</a:t>
+            </a:r>
+            <a:endParaRPr lang="en-US" sz="1100" dirty="0"/>
+          </a:p>
+        </p:txBody>
+      </p:sp>
+    </p:spTree>
+  </p:cSld>
+  <p:clrMapOvr>
+    <a:masterClrMapping/>
+  </p:clrMapOvr>
+</p:sld>
+</file>
+
 <file path=ppt/slides/slide3.xml><?xml version="1.0" encoding="utf-8"?>
 <p:sld xmlns:a="http://schemas.openxmlformats.org/drawingml/2006/main" xmlns:r="http://schemas.openxmlformats.org/officeDocument/2006/relationships" xmlns:p="http://schemas.openxmlformats.org/presentationml/2006/main">
   <p:cSld name="Slide 3">
@@ -15084,7 +15334,7 @@
                 <a:ea typeface="Calibri" pitchFamily="34" charset="-122"/>
                 <a:cs typeface="Calibri" pitchFamily="34" charset="-120"/>
               </a:rPr>
-              <a:t>3 / 20</a:t>
+              <a:t>3 / 21</a:t>
             </a:r>
             <a:endParaRPr lang="en-US" sz="1000" dirty="0"/>
           </a:p>
@@ -15631,7 +15881,7 @@
                 <a:ea typeface="Calibri" pitchFamily="34" charset="-122"/>
                 <a:cs typeface="Calibri" pitchFamily="34" charset="-120"/>
               </a:rPr>
-              <a:t>4 / 20</a:t>
+              <a:t>4 / 21</a:t>
             </a:r>
             <a:endParaRPr lang="en-US" sz="1000" dirty="0"/>
           </a:p>
@@ -16416,7 +16666,7 @@
                 <a:ea typeface="Calibri" pitchFamily="34" charset="-122"/>
                 <a:cs typeface="Calibri" pitchFamily="34" charset="-120"/>
               </a:rPr>
-              <a:t>5 / 20</a:t>
+              <a:t>5 / 21</a:t>
             </a:r>
             <a:endParaRPr lang="en-US" sz="1000" dirty="0"/>
           </a:p>
@@ -17144,7 +17394,7 @@
                 <a:ea typeface="Calibri" pitchFamily="34" charset="-122"/>
                 <a:cs typeface="Calibri" pitchFamily="34" charset="-120"/>
               </a:rPr>
-              <a:t>6 / 20</a:t>
+              <a:t>6 / 21</a:t>
             </a:r>
             <a:endParaRPr lang="en-US" sz="1000" dirty="0"/>
           </a:p>
@@ -17745,7 +17995,7 @@
                 <a:ea typeface="Calibri" pitchFamily="34" charset="-122"/>
                 <a:cs typeface="Calibri" pitchFamily="34" charset="-120"/>
               </a:rPr>
-              <a:t>7 / 20</a:t>
+              <a:t>7 / 21</a:t>
             </a:r>
             <a:endParaRPr lang="en-US" sz="1000" dirty="0"/>
           </a:p>
@@ -18586,7 +18836,7 @@
                 <a:ea typeface="Calibri" pitchFamily="34" charset="-122"/>
                 <a:cs typeface="Calibri" pitchFamily="34" charset="-120"/>
               </a:rPr>
-              <a:t>8 / 20</a:t>
+              <a:t>8 / 21</a:t>
             </a:r>
             <a:endParaRPr lang="en-US" sz="1000" dirty="0"/>
           </a:p>
@@ -18955,7 +19205,7 @@
                 <a:ea typeface="Calibri" pitchFamily="34" charset="-122"/>
                 <a:cs typeface="Calibri" pitchFamily="34" charset="-120"/>
               </a:rPr>
-              <a:t>9 / 20</a:t>
+              <a:t>9 / 21</a:t>
             </a:r>
             <a:endParaRPr lang="en-US" sz="1000" dirty="0"/>
           </a:p>

</xml_diff>

<commit_message>
Heatmap del benchmark legible: layout 12 configs (SE x nivel) x 3 radios, 6 paneles por metrica
Regenera fig_heatmap_tophat.png con anotaciones sin solapamiento (make_heatmap_figure.py).
Reincorporado en la presentacion de avance (S14) y en la tesis (Figura 5).
</commit_message>
<xml_diff>
--- a/docs/Tesis_Avance_Presentacion.pptx
+++ b/docs/Tesis_Avance_Presentacion.pptx
@@ -4816,7 +4816,7 @@
           <p:nvPr/>
         </p:nvPicPr>
         <p:blipFill>
-          <a:blip r:embed="rId2"/>
+          <a:blip r:embed="rId3"/>
           <a:stretch>
             <a:fillRect/>
           </a:stretch>
@@ -4824,7 +4824,7 @@
         <p:spPr>
           <a:xfrm>
             <a:off x="2817932" y="1508760"/>
-            <a:ext cx="6525655" cy="3657600"/>
+            <a:ext cx="6525655" cy="4307534"/>
           </a:xfrm>
           <a:prstGeom prst="rect">
             <a:avLst/>

</xml_diff>